<commit_message>
Add all project files
</commit_message>
<xml_diff>
--- a/output/broll_001.pptx
+++ b/output/broll_001.pptx
@@ -3169,7 +3169,7 @@
                 </a:solidFill>
                 <a:latin typeface="Calibri"/>
               </a:rPr>
-              <a:t>Private Networks and Subnetting</a:t>
+              <a:t>Private Cloud Solutions</a:t>
             </a:r>
           </a:p>
         </p:txBody>
@@ -3284,7 +3284,7 @@
                 </a:solidFill>
                 <a:latin typeface="Calibri"/>
               </a:rPr>
-              <a:t>Public-facing websites and secure databases/payment systems are vulnerable to attacks.</a:t>
+              <a:t>Need for isolated and scalable networks in cloud computing</a:t>
             </a:r>
           </a:p>
         </p:txBody>
@@ -3434,7 +3434,7 @@
                 </a:solidFill>
                 <a:latin typeface="Calibri"/>
               </a:rPr>
-              <a:t>Private networks and subnetting separate public-facing websites from secure databases and payment systems, enhancing security.</a:t>
+              <a:t>AWS VPC and Azure VNet for creating private, scalable networks</a:t>
             </a:r>
           </a:p>
         </p:txBody>

</xml_diff>